<commit_message>
Organize dated meeting reports
</commit_message>
<xml_diff>
--- a/03-28/03.28-组会报告-刘子豪.pptx
+++ b/03-28/03.28-组会报告-刘子豪.pptx
@@ -3911,7 +3911,7 @@
                 <a:latin typeface="Microsoft YaHei" panose="020B0503020204020204" pitchFamily="34" charset="-122"/>
                 <a:ea typeface="Microsoft YaHei" panose="020B0503020204020204" pitchFamily="34" charset="-122"/>
               </a:rPr>
-              <a:t>—2026</a:t>
+              <a:t>—2026年03月28日—</a:t>
             </a:r>
             <a:r>
               <a:rPr lang="zh-CN" altLang="en-US" b="1" dirty="0">
@@ -3928,7 +3928,7 @@
                 <a:latin typeface="Microsoft YaHei" panose="020B0503020204020204" pitchFamily="34" charset="-122"/>
                 <a:ea typeface="Microsoft YaHei" panose="020B0503020204020204" pitchFamily="34" charset="-122"/>
               </a:rPr>
-              <a:t>年</a:t>
+              <a:t/>
             </a:r>
             <a:r>
               <a:rPr lang="en-US" altLang="zh-CN" b="1" dirty="0">
@@ -3945,7 +3945,7 @@
                 <a:latin typeface="Microsoft YaHei" panose="020B0503020204020204" pitchFamily="34" charset="-122"/>
                 <a:ea typeface="Microsoft YaHei" panose="020B0503020204020204" pitchFamily="34" charset="-122"/>
               </a:rPr>
-              <a:t>03</a:t>
+              <a:t/>
             </a:r>
             <a:r>
               <a:rPr lang="zh-CN" altLang="en-US" b="1" dirty="0">
@@ -3962,7 +3962,7 @@
                 <a:latin typeface="Microsoft YaHei" panose="020B0503020204020204" pitchFamily="34" charset="-122"/>
                 <a:ea typeface="Microsoft YaHei" panose="020B0503020204020204" pitchFamily="34" charset="-122"/>
               </a:rPr>
-              <a:t>月</a:t>
+              <a:t/>
             </a:r>
             <a:r>
               <a:rPr lang="en-US" altLang="zh-CN" b="1" dirty="0">
@@ -3979,7 +3979,7 @@
                 <a:latin typeface="Microsoft YaHei" panose="020B0503020204020204" pitchFamily="34" charset="-122"/>
                 <a:ea typeface="Microsoft YaHei" panose="020B0503020204020204" pitchFamily="34" charset="-122"/>
               </a:rPr>
-              <a:t>28</a:t>
+              <a:t/>
             </a:r>
             <a:r>
               <a:rPr lang="zh-CN" altLang="en-US" b="1" dirty="0">
@@ -3996,7 +3996,7 @@
                 <a:latin typeface="Microsoft YaHei" panose="020B0503020204020204" pitchFamily="34" charset="-122"/>
                 <a:ea typeface="Microsoft YaHei" panose="020B0503020204020204" pitchFamily="34" charset="-122"/>
               </a:rPr>
-              <a:t>日</a:t>
+              <a:t/>
             </a:r>
             <a:r>
               <a:rPr lang="en-US" altLang="zh-CN" b="1" dirty="0">
@@ -4013,7 +4013,7 @@
                 <a:latin typeface="Microsoft YaHei" panose="020B0503020204020204" pitchFamily="34" charset="-122"/>
                 <a:ea typeface="Microsoft YaHei" panose="020B0503020204020204" pitchFamily="34" charset="-122"/>
               </a:rPr>
-              <a:t>—</a:t>
+              <a:t/>
             </a:r>
             <a:endParaRPr lang="zh-CN" altLang="en-US" dirty="0"/>
           </a:p>

</xml_diff>